<commit_message>
Rewrite the two-slide executive summary around business outcomes
Patients reached sooner, care-team tools changed faster, routine calls
handled, lower cost and patient data kept safe; agent names, data layers
and gate codes left to the full deck. The timeline runs pilot to scale in
six business steps.

Co-Authored-By: Claude Opus 5.5 <noreply@anthropic.com>
Claude-Session: https://claude.ai/code/session_01Hf94kqMzSofkkrQm7kpNba
</commit_message>
<xml_diff>
--- a/poc/data_harness/Ascension Agentic Factory - Executive Summary (2 slides).pptx
+++ b/poc/data_harness/Ascension Agentic Factory - Executive Summary (2 slides).pptx
@@ -1425,7 +1425,7 @@
           </a:p>
           <a:p>
             <a:r>
-              <a:t>Ascension wants faster Salesforce delivery and faster Marketing Cloud campaigns without loosening control of patient data. Today a Health Cloud change takes about two weeks and a campaign about 90 days; much of that is manual research, impact analysis, test writing, and data preparation repeated for every campaign. The Agentic Factory brings AI agents to Health Cloud delivery, Marketing Cloud campaigns and the Sierra voice agent on one governed platform. We start with one Health Cloud pod and one campaign, then add pods one at a time.</a:t>
+              <a:t>Ascension wants to use AI to reach patients sooner, serve them better and run its digital operations at lower cost, without putting patient data at risk. Today a patient-outreach campaign takes about 90 days to launch, a change to care-team tools in Salesforce takes about two weeks, and routine patient calls depend on staff. The Ascension Agentic Factory brings AI to all three on one secure, HIPAA-aligned platform. We start with post-discharge follow-up for heart-failure patients and the Network Services team, then add programs and teams.</a:t>
             </a:r>
           </a:p>
           <a:p/>
@@ -1436,7 +1436,7 @@
           </a:p>
           <a:p>
             <a:r>
-              <a:t>About 2 days per Health Cloud change instead of about 2 weeks; about 10-12 days per campaign instead of about 90; squads of about 2.4 people instead of 5-7; about $19.9M saved over three years. All are pilot targets and planning estimates, confirmed against the Phase 0 baseline.</a:t>
+              <a:t>Campaigns in about 10-12 days instead of about 90; care-team changes in about 2 days instead of about 2 weeks; consent checked before every message; routine calls answered by the voice agent with a hand-off to staff; about $19.9M saved over three years. The figures are pilot targets and planning estimates, confirmed against today's baseline.</a:t>
             </a:r>
           </a:p>
           <a:p/>
@@ -1447,7 +1447,7 @@
           </a:p>
           <a:p>
             <a:r>
-              <a:t>It runs on what Ascension already owns; agent-assisted delivery is already measured at Ascension (1-2 weeks to 2-4 days); safety is designed in; the Change Guardian protects every pod; and the rollout is measured and incremental.</a:t>
+              <a:t>Healthcare-ready and HIPAA-aligned by design; already proven at Ascension (agent-assisted delivery took changes from 1-2 weeks to 2-4 days); built on Ascension's existing Salesforce, Google Cloud and Codex; outcome-led and delivered in small releases.</a:t>
             </a:r>
           </a:p>
         </p:txBody>
@@ -1504,7 +1504,7 @@
           </a:p>
           <a:p>
             <a:r>
-              <a:t>Insight Global designs and implements the Ascension Agentic Factory: seven delivery agents and seven campaign agents, an engineering knowledge graph of Ascension's Salesforce estate, and a data harness in Google Cloud that governs patient data through Bronze, Silver and Gold layers with DLP and Collibra. Agents plan, build and test on masked data; people approve at every gate; patients reach Marketing Cloud only through a policy-checked activation gateway.</a:t>
+              <a:t>Insight Global designs and implements an AI solution for three parts of Ascension's business: patient-outreach campaigns in Marketing Cloud, changes to care-team tools in Salesforce Health Cloud, and the voice agent that answers patients and manages appointments. AI agents do the research, building and testing; Ascension's people approve every step; patient data stays in Ascension's Google Cloud, governed and masked.</a:t>
             </a:r>
           </a:p>
           <a:p/>
@@ -1515,7 +1515,7 @@
           </a:p>
           <a:p>
             <a:r>
-              <a:t>No raw PHI for agents, and masking alone is not HIPAA compliance; people approve every gate; existing platforms and data are reused; everything is proven on synthetic data before any real patient; releases are incremental; outcomes are measured.</a:t>
+              <a:t>Patient safety and HIPAA come first; people stay in control; existing investments are reused; everything is proven on test data before any real patient; releases are small and frequent; outcomes are measured.</a:t>
             </a:r>
           </a:p>
           <a:p/>
@@ -1526,7 +1526,7 @@
           </a:p>
           <a:p>
             <a:r>
-              <a:t>The seven build phases of the full deck, in order: discovery and baseline; the data foundation; PHI governance (its exit is a hard gate: zero unauthorized access in tests); agentic intelligence; build and test on synthetic data; governed activation with the first real CHF audience; then measure against the baseline and scale pod by pod. Phases 1 and 2 run partly in parallel. Durations are set in Phase 0. The Network Services Health Cloud pilot runs alongside, on the same agents and knowledge graph.</a:t>
+              <a:t>Six steps: agree goals and measure today; set up the secure data foundation; ready the AI agents on Ascension's own systems and rules; build and test the first campaign on test data; reach the first real patients; then measure and scale to more programs, teams and the voice agent. Durations are agreed in discovery. Care-team changes for the Network Services team start once the agents are ready.</a:t>
             </a:r>
           </a:p>
         </p:txBody>
@@ -2917,7 +2917,7 @@
                 </a:solidFill>
                 <a:latin typeface="Trenda IG Text"/>
               </a:rPr>
-              <a:t>Ascension is seeking to speed up Salesforce delivery and Marketing Cloud campaigns while keeping patient data governed. Today a Health Cloud change takes about two weeks and a campaign about 90 days, much of it manual research, impact analysis, test writing and data preparation repeated for every campaign. The Agentic Factory brings AI agents to Health Cloud delivery, Marketing Cloud campaigns and the Sierra voice agent, on one governed platform.</a:t>
+              <a:t>Ascension is seeking to use AI to reach patients sooner, serve them better and run its digital operations at lower cost, without putting patient data at risk. Today a patient-outreach campaign takes about 90 days to launch, a change to care-team tools in Salesforce takes about two weeks, and routine patient calls depend on staff. The Ascension Agentic Factory brings AI to all three, on one secure, HIPAA-aligned platform.</a:t>
             </a:r>
           </a:p>
           <a:p>
@@ -2936,7 +2936,7 @@
                 </a:solidFill>
                 <a:latin typeface="Trenda IG Text"/>
               </a:rPr>
-              <a:t>The initial focus will be one Health Cloud pod (Network Services) and one campaign (the CHF post-discharge nudge), followed by a pod-by-pod rollout, using a measured pilot and incremental releases.</a:t>
+              <a:t>The initial focus will be post-discharge follow-up for heart-failure patients and the Network Services team, followed by more patient programs and teams, using a measured pilot and incremental releases.</a:t>
             </a:r>
           </a:p>
         </p:txBody>
@@ -3009,7 +3009,7 @@
                 </a:solidFill>
                 <a:latin typeface="Trenda IG Text"/>
               </a:rPr>
-              <a:t>The solution addresses slow, manual delivery, data preparation rebuilt for every campaign, and the risk of one pod's change breaking another. Success will be measured by cycle time, first-pass approval, defects after release and zero unauthorized access to patient data.</a:t>
+              <a:t>The solution addresses slow launches of patient programs, manual work repeated for every campaign and change, routine calls that tie up staff, and the risk that comes with patient data. Success will be measured by time to launch, patients reached, cost per change and zero unauthorized access to patient data.</a:t>
             </a:r>
           </a:p>
         </p:txBody>
@@ -3023,7 +3023,7 @@
         <p:spPr>
           <a:xfrm>
             <a:off x="411480" y="4343400"/>
-            <a:ext cx="6172200" cy="1737360"/>
+            <a:ext cx="6172200" cy="1920240"/>
           </a:xfrm>
           <a:prstGeom prst="rect">
             <a:avLst/>
@@ -3049,7 +3049,7 @@
                 </a:solidFill>
                 <a:latin typeface="Trenda IG Text"/>
               </a:rPr>
-              <a:t>Health Cloud change: ~2 weeks to ~2 days, story to production</a:t>
+              <a:t>Launch patient-outreach campaigns in ~10-12 days, not ~90</a:t>
             </a:r>
           </a:p>
           <a:p>
@@ -3066,7 +3066,7 @@
                 </a:solidFill>
                 <a:latin typeface="Trenda IG Text"/>
               </a:rPr>
-              <a:t>Campaign launch: ~90 days to ~10-12 days</a:t>
+              <a:t>Deliver care-team tool changes in ~2 days, not ~2 weeks</a:t>
             </a:r>
           </a:p>
           <a:p>
@@ -3083,7 +3083,7 @@
                 </a:solidFill>
                 <a:latin typeface="Trenda IG Text"/>
               </a:rPr>
-              <a:t>Leaner squads: 5-7 people to about 2.4</a:t>
+              <a:t>Reach the right patients, with consent checked before every message</a:t>
             </a:r>
           </a:p>
           <a:p>
@@ -3100,7 +3100,7 @@
                 </a:solidFill>
                 <a:latin typeface="Trenda IG Text"/>
               </a:rPr>
-              <a:t>About $19.9M saved over three years</a:t>
+              <a:t>Handle routine patient calls with the voice agent; staff take the rest</a:t>
             </a:r>
           </a:p>
           <a:p>
@@ -3117,7 +3117,7 @@
                 </a:solidFill>
                 <a:latin typeface="Trenda IG Text"/>
               </a:rPr>
-              <a:t>Agents never see raw PHI; people approve every gate</a:t>
+              <a:t>Save about $19.9M over three years</a:t>
             </a:r>
           </a:p>
           <a:p>
@@ -3134,7 +3134,7 @@
                 </a:solidFill>
                 <a:latin typeface="Trenda IG Text"/>
               </a:rPr>
-              <a:t>A reusable foundation: new pods add skills, not rebuilds</a:t>
+              <a:t>Build a scalable AI foundation for future programs</a:t>
             </a:r>
           </a:p>
         </p:txBody>
@@ -3244,7 +3244,7 @@
                 </a:solidFill>
                 <a:latin typeface="Trenda IG Text"/>
               </a:rPr>
-              <a:t>Built on what Ascension already runs: Codex, Salesforce, Google Cloud, Collibra, Copado</a:t>
+              <a:t>Healthcare-ready: HIPAA-aligned by design; AI never sees raw patient data</a:t>
             </a:r>
           </a:p>
           <a:p>
@@ -3261,7 +3261,7 @@
                 </a:solidFill>
                 <a:latin typeface="Trenda IG Text"/>
               </a:rPr>
-              <a:t>Agent-assisted delivery already measured at Ascension: 1-2 weeks to 2-4 days</a:t>
+              <a:t>Proven at Ascension: agent-assisted delivery already took changes from 1-2 weeks to 2-4 days</a:t>
             </a:r>
           </a:p>
           <a:p>
@@ -3278,7 +3278,7 @@
                 </a:solidFill>
                 <a:latin typeface="Trenda IG Text"/>
               </a:rPr>
-              <a:t>HIPAA-aligned by design: no raw PHI for agents, no production credentials</a:t>
+              <a:t>Built on Ascension's existing Salesforce, Google Cloud and Codex investments</a:t>
             </a:r>
           </a:p>
           <a:p>
@@ -3295,7 +3295,7 @@
                 </a:solidFill>
                 <a:latin typeface="Trenda IG Text"/>
               </a:rPr>
-              <a:t>Change Guardian: no pod breaks another</a:t>
+              <a:t>Outcome-led delivery with measurable success criteria</a:t>
             </a:r>
           </a:p>
           <a:p>
@@ -3312,7 +3312,7 @@
                 </a:solidFill>
                 <a:latin typeface="Trenda IG Text"/>
               </a:rPr>
-              <a:t>Outcome-led pilot with measurable success criteria</a:t>
+              <a:t>Iterative MVP approach: early value, not a big-bang launch</a:t>
             </a:r>
           </a:p>
           <a:p>
@@ -3329,7 +3329,7 @@
                 </a:solidFill>
                 <a:latin typeface="Trenda IG Text"/>
               </a:rPr>
-              <a:t>Incremental, pod-by-pod rollout, not a big-bang launch</a:t>
+              <a:t>People stay in control: every AI recommendation is approved</a:t>
             </a:r>
           </a:p>
         </p:txBody>
@@ -3513,7 +3513,7 @@
         <p:spPr>
           <a:xfrm>
             <a:off x="411480" y="1673352"/>
-            <a:ext cx="6035040" cy="2194560"/>
+            <a:ext cx="6035040" cy="2103120"/>
           </a:xfrm>
           <a:prstGeom prst="rect">
             <a:avLst/>
@@ -3538,7 +3538,7 @@
                 </a:solidFill>
                 <a:latin typeface="Trenda IG Text"/>
               </a:rPr>
-              <a:t>Insight Global will design and implement the Ascension Agentic Factory: seven delivery agents and seven campaign agents, an engineering knowledge graph of Ascension's Salesforce estate, and a data harness in Google Cloud that governs patient data through Bronze, Silver and Gold layers with DLP and Collibra. Agents plan, build and test on masked data; people approve at every gate; patients reach Marketing Cloud only through a policy-checked activation gateway. Delivery follows a measured pilot, then pod by pod.</a:t>
+              <a:t>Insight Global will design and implement an AI solution for three parts of Ascension's business: patient-outreach campaigns in Marketing Cloud, faster changes to care-team tools in Salesforce Health Cloud, and a voice agent that answers patients and manages their appointments. AI agents do the research, building and testing; Ascension's people approve every step; patient data stays in Ascension's Google Cloud, governed and masked. Delivery follows a measured pilot, providing early value while establishing a scalable foundation for every team.</a:t>
             </a:r>
           </a:p>
         </p:txBody>
@@ -3586,7 +3586,7 @@
         <p:spPr>
           <a:xfrm>
             <a:off x="6903720" y="1691640"/>
-            <a:ext cx="4873752" cy="2194560"/>
+            <a:ext cx="4873752" cy="2103120"/>
           </a:xfrm>
           <a:prstGeom prst="rect">
             <a:avLst/>
@@ -3612,7 +3612,7 @@
                 </a:solidFill>
                 <a:latin typeface="Trenda IG Text"/>
               </a:rPr>
-              <a:t>Agents never see raw PHI; masking alone is not HIPAA compliance</a:t>
+              <a:t>Patient safety and HIPAA first: consent checked before every message</a:t>
             </a:r>
           </a:p>
           <a:p>
@@ -3629,7 +3629,7 @@
                 </a:solidFill>
                 <a:latin typeface="Trenda IG Text"/>
               </a:rPr>
-              <a:t>People approve every gate: H1-H4 and CAB, G1-G3</a:t>
+              <a:t>People stay in control: every AI recommendation is approved</a:t>
             </a:r>
           </a:p>
           <a:p>
@@ -3646,7 +3646,7 @@
                 </a:solidFill>
                 <a:latin typeface="Trenda IG Text"/>
               </a:rPr>
-              <a:t>Existing platforms and data reused: Codex, Salesforce, Google Cloud, Collibra, Copado</a:t>
+              <a:t>Existing Salesforce, Google Cloud and Codex investments reused</a:t>
             </a:r>
           </a:p>
           <a:p>
@@ -3663,7 +3663,7 @@
                 </a:solidFill>
                 <a:latin typeface="Trenda IG Text"/>
               </a:rPr>
-              <a:t>Proven on synthetic data before any real patient</a:t>
+              <a:t>Proven on test data before any real patient</a:t>
             </a:r>
           </a:p>
           <a:p>
@@ -3697,7 +3697,7 @@
                 </a:solidFill>
                 <a:latin typeface="Trenda IG Text"/>
               </a:rPr>
-              <a:t>Measurable speed, quality and safety outcomes</a:t>
+              <a:t>Measurable outcomes: speed, reach, cost and safety</a:t>
             </a:r>
           </a:p>
         </p:txBody>
@@ -3740,14 +3740,48 @@
                 </a:solidFill>
                 <a:latin typeface="Trenda IG Text"/>
               </a:rPr>
-              <a:t>Phased pilot</a:t>
+              <a:t>Pilot to scale</a:t>
             </a:r>
           </a:p>
         </p:txBody>
       </p:sp>
       <p:sp>
         <p:nvSpPr>
-          <p:cNvPr id="10" name="Shape 9"/>
+          <p:cNvPr id="10" name="Text 9"/>
+          <p:cNvSpPr txBox="1"/>
+          <p:nvPr/>
+        </p:nvSpPr>
+        <p:spPr>
+          <a:xfrm>
+            <a:off x="411480" y="4370832"/>
+            <a:ext cx="11338560" cy="201168"/>
+          </a:xfrm>
+          <a:prstGeom prst="rect">
+            <a:avLst/>
+          </a:prstGeom>
+          <a:noFill/>
+        </p:spPr>
+        <p:txBody>
+          <a:bodyPr wrap="square" lIns="0" rIns="0" tIns="0" bIns="0" anchor="ctr">
+            <a:spAutoFit/>
+          </a:bodyPr>
+          <a:lstStyle/>
+          <a:p>
+            <a:r>
+              <a:rPr sz="850" b="0" i="0">
+                <a:solidFill>
+                  <a:srgbClr val="8C8C8C"/>
+                </a:solidFill>
+                <a:latin typeface="Trenda IG Text"/>
+              </a:rPr>
+              <a:t>Durations are agreed in discovery. Care-team changes for the Network Services team start once the AI agents are ready.</a:t>
+            </a:r>
+          </a:p>
+        </p:txBody>
+      </p:sp>
+      <p:sp>
+        <p:nvSpPr>
+          <p:cNvPr id="11" name="Shape 10"/>
           <p:cNvSpPr/>
           <p:nvPr/>
         </p:nvSpPr>
@@ -3800,7 +3834,7 @@
       </p:sp>
       <p:cxnSp>
         <p:nvCxnSpPr>
-          <p:cNvPr id="11" name="Arrow 10"/>
+          <p:cNvPr id="12" name="Arrow 11"/>
           <p:cNvCxnSpPr/>
           <p:nvPr/>
         </p:nvCxnSpPr>
@@ -3836,7 +3870,7 @@
       </p:cxnSp>
       <p:sp>
         <p:nvSpPr>
-          <p:cNvPr id="12" name="Shape 11"/>
+          <p:cNvPr id="13" name="Shape 12"/>
           <p:cNvSpPr/>
           <p:nvPr/>
         </p:nvSpPr>
@@ -3878,14 +3912,14 @@
       </p:sp>
       <p:sp>
         <p:nvSpPr>
-          <p:cNvPr id="13" name="Text 12"/>
+          <p:cNvPr id="14" name="Text 13"/>
           <p:cNvSpPr txBox="1"/>
           <p:nvPr/>
         </p:nvSpPr>
         <p:spPr>
           <a:xfrm>
             <a:off x="594359" y="4526280"/>
-            <a:ext cx="2331720" cy="502920"/>
+            <a:ext cx="2194560" cy="502920"/>
           </a:xfrm>
           <a:prstGeom prst="rect">
             <a:avLst/>
@@ -3910,7 +3944,7 @@
                 </a:solidFill>
                 <a:latin typeface="Trenda IG Text"/>
               </a:rPr>
-              <a:t>Phase 0 · Discovery &amp; baseline</a:t>
+              <a:t>Discovery &amp; baseline</a:t>
             </a:r>
           </a:p>
           <a:p>
@@ -3926,20 +3960,20 @@
                 </a:solidFill>
                 <a:latin typeface="Trenda IG Text"/>
               </a:rPr>
-              <a:t>owners, architecture, today's measures</a:t>
+              <a:t>goals, owners, today's measures</a:t>
             </a:r>
           </a:p>
         </p:txBody>
       </p:sp>
       <p:cxnSp>
         <p:nvCxnSpPr>
-          <p:cNvPr id="14" name="Arrow 13"/>
+          <p:cNvPr id="15" name="Arrow 14"/>
           <p:cNvCxnSpPr/>
           <p:nvPr/>
         </p:nvCxnSpPr>
         <p:spPr>
           <a:xfrm>
-            <a:off x="2453640" y="5504688"/>
+            <a:off x="2816352" y="5504688"/>
             <a:ext cx="0" cy="256032"/>
           </a:xfrm>
           <a:prstGeom prst="line">
@@ -3969,13 +4003,13 @@
       </p:cxnSp>
       <p:sp>
         <p:nvSpPr>
-          <p:cNvPr id="15" name="Shape 14"/>
+          <p:cNvPr id="16" name="Shape 15"/>
           <p:cNvSpPr/>
           <p:nvPr/>
         </p:nvSpPr>
         <p:spPr>
           <a:xfrm>
-            <a:off x="2380488" y="5340096"/>
+            <a:off x="2743200" y="5340096"/>
             <a:ext cx="146304" cy="146304"/>
           </a:xfrm>
           <a:prstGeom prst="ellipse">
@@ -4011,14 +4045,14 @@
       </p:sp>
       <p:sp>
         <p:nvSpPr>
-          <p:cNvPr id="16" name="Text 15"/>
+          <p:cNvPr id="17" name="Text 16"/>
           <p:cNvSpPr txBox="1"/>
           <p:nvPr/>
         </p:nvSpPr>
         <p:spPr>
           <a:xfrm>
-            <a:off x="2407920" y="5806440"/>
-            <a:ext cx="2331720" cy="502920"/>
+            <a:off x="2770632" y="5806440"/>
+            <a:ext cx="2194560" cy="502920"/>
           </a:xfrm>
           <a:prstGeom prst="rect">
             <a:avLst/>
@@ -4043,7 +4077,7 @@
                 </a:solidFill>
                 <a:latin typeface="Trenda IG Text"/>
               </a:rPr>
-              <a:t>Phase 1 · Data foundation</a:t>
+              <a:t>Secure data foundation</a:t>
             </a:r>
           </a:p>
           <a:p>
@@ -4059,20 +4093,20 @@
                 </a:solidFill>
                 <a:latin typeface="Trenda IG Text"/>
               </a:rPr>
-              <a:t>Bronze, Silver, Gold in Google Cloud</a:t>
+              <a:t>patient data governed in Google Cloud</a:t>
             </a:r>
           </a:p>
         </p:txBody>
       </p:sp>
       <p:cxnSp>
         <p:nvCxnSpPr>
-          <p:cNvPr id="17" name="Arrow 16"/>
+          <p:cNvPr id="18" name="Arrow 17"/>
           <p:cNvCxnSpPr/>
           <p:nvPr/>
         </p:nvCxnSpPr>
         <p:spPr>
           <a:xfrm>
-            <a:off x="4267200" y="5065776"/>
+            <a:off x="4992624" y="5065776"/>
             <a:ext cx="0" cy="256032"/>
           </a:xfrm>
           <a:prstGeom prst="line">
@@ -4102,13 +4136,13 @@
       </p:cxnSp>
       <p:sp>
         <p:nvSpPr>
-          <p:cNvPr id="18" name="Shape 17"/>
+          <p:cNvPr id="19" name="Shape 18"/>
           <p:cNvSpPr/>
           <p:nvPr/>
         </p:nvSpPr>
         <p:spPr>
           <a:xfrm>
-            <a:off x="4194048" y="5340096"/>
+            <a:off x="4919472" y="5340096"/>
             <a:ext cx="146304" cy="146304"/>
           </a:xfrm>
           <a:prstGeom prst="ellipse">
@@ -4144,14 +4178,14 @@
       </p:sp>
       <p:sp>
         <p:nvSpPr>
-          <p:cNvPr id="19" name="Text 18"/>
+          <p:cNvPr id="20" name="Text 19"/>
           <p:cNvSpPr txBox="1"/>
           <p:nvPr/>
         </p:nvSpPr>
         <p:spPr>
           <a:xfrm>
-            <a:off x="4221480" y="4526280"/>
-            <a:ext cx="2331720" cy="502920"/>
+            <a:off x="4946904" y="4526280"/>
+            <a:ext cx="2194560" cy="502920"/>
           </a:xfrm>
           <a:prstGeom prst="rect">
             <a:avLst/>
@@ -4176,7 +4210,7 @@
                 </a:solidFill>
                 <a:latin typeface="Trenda IG Text"/>
               </a:rPr>
-              <a:t>Phase 2 · PHI governance</a:t>
+              <a:t>AI agents ready</a:t>
             </a:r>
           </a:p>
           <a:p>
@@ -4192,20 +4226,20 @@
                 </a:solidFill>
                 <a:latin typeface="Trenda IG Text"/>
               </a:rPr>
-              <a:t>DLP, Collibra; zero unauthorized access</a:t>
+              <a:t>trained on Ascension's systems and rules</a:t>
             </a:r>
           </a:p>
         </p:txBody>
       </p:sp>
       <p:cxnSp>
         <p:nvCxnSpPr>
-          <p:cNvPr id="20" name="Arrow 19"/>
+          <p:cNvPr id="21" name="Arrow 20"/>
           <p:cNvCxnSpPr/>
           <p:nvPr/>
         </p:nvCxnSpPr>
         <p:spPr>
           <a:xfrm>
-            <a:off x="6080760" y="5504688"/>
+            <a:off x="7168896" y="5504688"/>
             <a:ext cx="0" cy="256032"/>
           </a:xfrm>
           <a:prstGeom prst="line">
@@ -4235,13 +4269,13 @@
       </p:cxnSp>
       <p:sp>
         <p:nvSpPr>
-          <p:cNvPr id="21" name="Shape 20"/>
+          <p:cNvPr id="22" name="Shape 21"/>
           <p:cNvSpPr/>
           <p:nvPr/>
         </p:nvSpPr>
         <p:spPr>
           <a:xfrm>
-            <a:off x="6007608" y="5340096"/>
+            <a:off x="7095744" y="5340096"/>
             <a:ext cx="146304" cy="146304"/>
           </a:xfrm>
           <a:prstGeom prst="ellipse">
@@ -4277,14 +4311,14 @@
       </p:sp>
       <p:sp>
         <p:nvSpPr>
-          <p:cNvPr id="22" name="Text 21"/>
+          <p:cNvPr id="23" name="Text 22"/>
           <p:cNvSpPr txBox="1"/>
           <p:nvPr/>
         </p:nvSpPr>
         <p:spPr>
           <a:xfrm>
-            <a:off x="6035040" y="5806440"/>
-            <a:ext cx="2331720" cy="502920"/>
+            <a:off x="7123176" y="5806440"/>
+            <a:ext cx="2194560" cy="502920"/>
           </a:xfrm>
           <a:prstGeom prst="rect">
             <a:avLst/>
@@ -4309,7 +4343,7 @@
                 </a:solidFill>
                 <a:latin typeface="Trenda IG Text"/>
               </a:rPr>
-              <a:t>Phase 3 · Agentic intelligence</a:t>
+              <a:t>First campaign built &amp; tested</a:t>
             </a:r>
           </a:p>
           <a:p>
@@ -4325,20 +4359,20 @@
                 </a:solidFill>
                 <a:latin typeface="Trenda IG Text"/>
               </a:rPr>
-              <a:t>knowledge graph, agents, first brief</a:t>
+              <a:t>heart-failure follow-up, on test data</a:t>
             </a:r>
           </a:p>
         </p:txBody>
       </p:sp>
       <p:cxnSp>
         <p:nvCxnSpPr>
-          <p:cNvPr id="23" name="Arrow 22"/>
+          <p:cNvPr id="24" name="Arrow 23"/>
           <p:cNvCxnSpPr/>
           <p:nvPr/>
         </p:nvCxnSpPr>
         <p:spPr>
           <a:xfrm>
-            <a:off x="7894320" y="5065776"/>
+            <a:off x="9345167" y="5065776"/>
             <a:ext cx="0" cy="256032"/>
           </a:xfrm>
           <a:prstGeom prst="line">
@@ -4368,13 +4402,13 @@
       </p:cxnSp>
       <p:sp>
         <p:nvSpPr>
-          <p:cNvPr id="24" name="Shape 23"/>
+          <p:cNvPr id="25" name="Shape 24"/>
           <p:cNvSpPr/>
           <p:nvPr/>
         </p:nvSpPr>
         <p:spPr>
           <a:xfrm>
-            <a:off x="7821167" y="5340096"/>
+            <a:off x="9272015" y="5340096"/>
             <a:ext cx="146304" cy="146304"/>
           </a:xfrm>
           <a:prstGeom prst="ellipse">
@@ -4410,14 +4444,14 @@
       </p:sp>
       <p:sp>
         <p:nvSpPr>
-          <p:cNvPr id="25" name="Text 24"/>
+          <p:cNvPr id="26" name="Text 25"/>
           <p:cNvSpPr txBox="1"/>
           <p:nvPr/>
         </p:nvSpPr>
         <p:spPr>
           <a:xfrm>
-            <a:off x="7848599" y="4526280"/>
-            <a:ext cx="1874519" cy="502920"/>
+            <a:off x="9299447" y="4526280"/>
+            <a:ext cx="2194560" cy="502920"/>
           </a:xfrm>
           <a:prstGeom prst="rect">
             <a:avLst/>
@@ -4442,7 +4476,7 @@
                 </a:solidFill>
                 <a:latin typeface="Trenda IG Text"/>
               </a:rPr>
-              <a:t>Phase 4 · Build &amp; test</a:t>
+              <a:t>First patients reached</a:t>
             </a:r>
           </a:p>
           <a:p>
@@ -4458,20 +4492,20 @@
                 </a:solidFill>
                 <a:latin typeface="Trenda IG Text"/>
               </a:rPr>
-              <a:t>tested; no real patient yet</a:t>
+              <a:t>live, with consent checked</a:t>
             </a:r>
           </a:p>
         </p:txBody>
       </p:sp>
       <p:cxnSp>
         <p:nvCxnSpPr>
-          <p:cNvPr id="26" name="Arrow 25"/>
+          <p:cNvPr id="27" name="Arrow 26"/>
           <p:cNvCxnSpPr/>
           <p:nvPr/>
         </p:nvCxnSpPr>
         <p:spPr>
           <a:xfrm>
-            <a:off x="9707879" y="5504688"/>
+            <a:off x="11521440" y="5504688"/>
             <a:ext cx="0" cy="256032"/>
           </a:xfrm>
           <a:prstGeom prst="line">
@@ -4501,140 +4535,7 @@
       </p:cxnSp>
       <p:sp>
         <p:nvSpPr>
-          <p:cNvPr id="27" name="Shape 26"/>
-          <p:cNvSpPr/>
-          <p:nvPr/>
-        </p:nvSpPr>
-        <p:spPr>
-          <a:xfrm>
-            <a:off x="9634727" y="5340096"/>
-            <a:ext cx="146304" cy="146304"/>
-          </a:xfrm>
-          <a:prstGeom prst="ellipse">
-            <a:avLst/>
-          </a:prstGeom>
-          <a:solidFill>
-            <a:srgbClr val="FFFFFF"/>
-          </a:solidFill>
-          <a:ln>
-            <a:noFill/>
-          </a:ln>
-          <a:effectLst/>
-        </p:spPr>
-        <p:style>
-          <a:lnRef idx="1">
-            <a:schemeClr val="accent1"/>
-          </a:lnRef>
-          <a:fillRef idx="3">
-            <a:schemeClr val="accent1"/>
-          </a:fillRef>
-          <a:effectRef idx="2">
-            <a:schemeClr val="accent1"/>
-          </a:effectRef>
-          <a:fontRef idx="minor">
-            <a:schemeClr val="lt1"/>
-          </a:fontRef>
-        </p:style>
-        <p:txBody>
-          <a:bodyPr rtlCol="0" anchor="ctr"/>
-          <a:lstStyle/>
-          <a:p/>
-        </p:txBody>
-      </p:sp>
-      <p:sp>
-        <p:nvSpPr>
-          <p:cNvPr id="28" name="Text 27"/>
-          <p:cNvSpPr txBox="1"/>
-          <p:nvPr/>
-        </p:nvSpPr>
-        <p:spPr>
-          <a:xfrm>
-            <a:off x="9662159" y="5806440"/>
-            <a:ext cx="1874519" cy="502920"/>
-          </a:xfrm>
-          <a:prstGeom prst="rect">
-            <a:avLst/>
-          </a:prstGeom>
-          <a:noFill/>
-        </p:spPr>
-        <p:txBody>
-          <a:bodyPr wrap="square" lIns="0" rIns="0" tIns="0" bIns="0" anchor="t">
-            <a:spAutoFit/>
-          </a:bodyPr>
-          <a:lstStyle/>
-          <a:p>
-            <a:pPr>
-              <a:spcAft>
-                <a:spcPts val="100"/>
-              </a:spcAft>
-            </a:pPr>
-            <a:r>
-              <a:rPr sz="1050" b="0" i="0">
-                <a:solidFill>
-                  <a:srgbClr val="FFFFFF"/>
-                </a:solidFill>
-                <a:latin typeface="Trenda IG Text"/>
-              </a:rPr>
-              <a:t>Phase 5 · Governed activation</a:t>
-            </a:r>
-          </a:p>
-          <a:p>
-            <a:pPr>
-              <a:spcAft>
-                <a:spcPts val="100"/>
-              </a:spcAft>
-            </a:pPr>
-            <a:r>
-              <a:rPr sz="950" b="0" i="0">
-                <a:solidFill>
-                  <a:srgbClr val="B3B3B3"/>
-                </a:solidFill>
-                <a:latin typeface="Trenda IG Text"/>
-              </a:rPr>
-              <a:t>the first real CHF audience</a:t>
-            </a:r>
-          </a:p>
-        </p:txBody>
-      </p:sp>
-      <p:cxnSp>
-        <p:nvCxnSpPr>
-          <p:cNvPr id="29" name="Arrow 28"/>
-          <p:cNvCxnSpPr/>
-          <p:nvPr/>
-        </p:nvCxnSpPr>
-        <p:spPr>
-          <a:xfrm>
-            <a:off x="11521440" y="5065776"/>
-            <a:ext cx="0" cy="256032"/>
-          </a:xfrm>
-          <a:prstGeom prst="line">
-            <a:avLst/>
-          </a:prstGeom>
-          <a:ln w="19050">
-            <a:solidFill>
-              <a:srgbClr val="FFFFFF"/>
-            </a:solidFill>
-            <a:prstDash val="sysDot"/>
-          </a:ln>
-        </p:spPr>
-        <p:style>
-          <a:lnRef idx="2">
-            <a:schemeClr val="accent1"/>
-          </a:lnRef>
-          <a:fillRef idx="0">
-            <a:schemeClr val="accent1"/>
-          </a:fillRef>
-          <a:effectRef idx="1">
-            <a:schemeClr val="accent1"/>
-          </a:effectRef>
-          <a:fontRef idx="minor">
-            <a:schemeClr val="tx1"/>
-          </a:fontRef>
-        </p:style>
-      </p:cxnSp>
-      <p:sp>
-        <p:nvSpPr>
-          <p:cNvPr id="30" name="Shape 29"/>
+          <p:cNvPr id="28" name="Shape 27"/>
           <p:cNvSpPr/>
           <p:nvPr/>
         </p:nvSpPr>
@@ -4676,14 +4577,14 @@
       </p:sp>
       <p:sp>
         <p:nvSpPr>
-          <p:cNvPr id="31" name="Text 30"/>
+          <p:cNvPr id="29" name="Text 28"/>
           <p:cNvSpPr txBox="1"/>
           <p:nvPr/>
         </p:nvSpPr>
         <p:spPr>
           <a:xfrm>
-            <a:off x="9692640" y="4526280"/>
-            <a:ext cx="1874519" cy="502920"/>
+            <a:off x="9372600" y="5806440"/>
+            <a:ext cx="2194560" cy="502920"/>
           </a:xfrm>
           <a:prstGeom prst="rect">
             <a:avLst/>
@@ -4691,7 +4592,7 @@
           <a:noFill/>
         </p:spPr>
         <p:txBody>
-          <a:bodyPr wrap="square" lIns="0" rIns="0" tIns="0" bIns="0" anchor="b">
+          <a:bodyPr wrap="square" lIns="0" rIns="0" tIns="0" bIns="0" anchor="t">
             <a:spAutoFit/>
           </a:bodyPr>
           <a:lstStyle/>
@@ -4708,7 +4609,7 @@
                 </a:solidFill>
                 <a:latin typeface="Trenda IG Text"/>
               </a:rPr>
-              <a:t>Phase 6 · Measure &amp; scale</a:t>
+              <a:t>Measure &amp; scale</a:t>
             </a:r>
           </a:p>
           <a:p>
@@ -4724,41 +4625,7 @@
                 </a:solidFill>
                 <a:latin typeface="Trenda IG Text"/>
               </a:rPr>
-              <a:t>vs the baseline; pod by pod</a:t>
-            </a:r>
-          </a:p>
-        </p:txBody>
-      </p:sp>
-      <p:sp>
-        <p:nvSpPr>
-          <p:cNvPr id="32" name="Text 31"/>
-          <p:cNvSpPr txBox="1"/>
-          <p:nvPr/>
-        </p:nvSpPr>
-        <p:spPr>
-          <a:xfrm>
-            <a:off x="411480" y="4370832"/>
-            <a:ext cx="11338560" cy="201168"/>
-          </a:xfrm>
-          <a:prstGeom prst="rect">
-            <a:avLst/>
-          </a:prstGeom>
-          <a:noFill/>
-        </p:spPr>
-        <p:txBody>
-          <a:bodyPr wrap="square" lIns="0" rIns="0" tIns="0" bIns="0" anchor="ctr">
-            <a:spAutoFit/>
-          </a:bodyPr>
-          <a:lstStyle/>
-          <a:p>
-            <a:r>
-              <a:rPr sz="850" b="0" i="0">
-                <a:solidFill>
-                  <a:srgbClr val="8C8C8C"/>
-                </a:solidFill>
-                <a:latin typeface="Trenda IG Text"/>
-              </a:rPr>
-              <a:t>Phases 1 and 2 run partly in parallel. Durations are set in Phase 0. The Network Services Health Cloud pilot runs alongside, on the same agents and knowledge graph.</a:t>
+              <a:t>more programs, teams, the voice agent</a:t>
             </a:r>
           </a:p>
         </p:txBody>

</xml_diff>